<commit_message>
Prioritize individual slide layout within a consistent visual tone
</commit_message>
<xml_diff>
--- a/slides/datasets-in-10-minutes-swe-bench-verified.pptx
+++ b/slides/datasets-in-10-minutes-swe-bench-verified.pptx
@@ -7671,7 +7671,7 @@
         </p:nvSpPr>
         <p:spPr>
           <a:xfrm>
-            <a:off x="548640" y="1508760"/>
+            <a:off x="548640" y="1869056"/>
             <a:ext cx="8046720" cy="1063625"/>
           </a:xfrm>
           <a:prstGeom prst="rect">
@@ -7805,7 +7805,7 @@
         </p:nvSpPr>
         <p:spPr>
           <a:xfrm>
-            <a:off x="594360" y="2773553"/>
+            <a:off x="594360" y="3133849"/>
             <a:ext cx="7955279" cy="777240"/>
           </a:xfrm>
           <a:prstGeom prst="rect">
@@ -8064,7 +8064,7 @@
         </p:nvSpPr>
         <p:spPr>
           <a:xfrm>
-            <a:off x="548640" y="1508760"/>
+            <a:off x="548640" y="2326820"/>
             <a:ext cx="8046720" cy="484187"/>
           </a:xfrm>
           <a:prstGeom prst="rect">
@@ -8136,7 +8136,7 @@
         </p:nvSpPr>
         <p:spPr>
           <a:xfrm>
-            <a:off x="594360" y="2194115"/>
+            <a:off x="594360" y="3012175"/>
             <a:ext cx="7955279" cy="777240"/>
           </a:xfrm>
           <a:prstGeom prst="rect">
@@ -8281,7 +8281,7 @@
         </p:nvSpPr>
         <p:spPr>
           <a:xfrm>
-            <a:off x="594360" y="1307592"/>
+            <a:off x="594360" y="2125652"/>
             <a:ext cx="7955279" cy="164592"/>
           </a:xfrm>
           <a:prstGeom prst="rect">
@@ -8909,7 +8909,7 @@
         </p:nvSpPr>
         <p:spPr>
           <a:xfrm>
-            <a:off x="548640" y="1508760"/>
+            <a:off x="548640" y="2172020"/>
             <a:ext cx="8046720" cy="793750"/>
           </a:xfrm>
           <a:prstGeom prst="rect">
@@ -9012,7 +9012,7 @@
         </p:nvSpPr>
         <p:spPr>
           <a:xfrm>
-            <a:off x="594360" y="2503678"/>
+            <a:off x="594360" y="3166938"/>
             <a:ext cx="7955279" cy="777240"/>
           </a:xfrm>
           <a:prstGeom prst="rect">
@@ -9157,7 +9157,7 @@
         </p:nvSpPr>
         <p:spPr>
           <a:xfrm>
-            <a:off x="594360" y="1307592"/>
+            <a:off x="594360" y="1970852"/>
             <a:ext cx="7955279" cy="164592"/>
           </a:xfrm>
           <a:prstGeom prst="rect">
@@ -10049,7 +10049,7 @@
         </p:nvSpPr>
         <p:spPr>
           <a:xfrm>
-            <a:off x="548640" y="1508760"/>
+            <a:off x="548640" y="1843703"/>
             <a:ext cx="8046720" cy="1111250"/>
           </a:xfrm>
           <a:prstGeom prst="rect">
@@ -10183,7 +10183,7 @@
         </p:nvSpPr>
         <p:spPr>
           <a:xfrm>
-            <a:off x="594360" y="2821178"/>
+            <a:off x="594360" y="3156121"/>
             <a:ext cx="7955279" cy="777240"/>
           </a:xfrm>
           <a:prstGeom prst="rect">
@@ -20131,7 +20131,7 @@
         </p:nvSpPr>
         <p:spPr>
           <a:xfrm>
-            <a:off x="548640" y="1508760"/>
+            <a:off x="548640" y="2310380"/>
             <a:ext cx="8046720" cy="515937"/>
           </a:xfrm>
           <a:prstGeom prst="rect">
@@ -20203,7 +20203,7 @@
         </p:nvSpPr>
         <p:spPr>
           <a:xfrm>
-            <a:off x="594360" y="2225865"/>
+            <a:off x="594360" y="3027485"/>
             <a:ext cx="7955279" cy="777240"/>
           </a:xfrm>
           <a:prstGeom prst="rect">
@@ -20348,7 +20348,7 @@
         </p:nvSpPr>
         <p:spPr>
           <a:xfrm>
-            <a:off x="594360" y="1307592"/>
+            <a:off x="594360" y="2109212"/>
             <a:ext cx="7955279" cy="164592"/>
           </a:xfrm>
           <a:prstGeom prst="rect">
@@ -20516,7 +20516,7 @@
         </p:nvSpPr>
         <p:spPr>
           <a:xfrm>
-            <a:off x="548640" y="1508760"/>
+            <a:off x="548640" y="2187438"/>
             <a:ext cx="8046720" cy="762000"/>
           </a:xfrm>
           <a:prstGeom prst="rect">
@@ -20619,7 +20619,7 @@
         </p:nvSpPr>
         <p:spPr>
           <a:xfrm>
-            <a:off x="594360" y="2471928"/>
+            <a:off x="594360" y="3150606"/>
             <a:ext cx="7955279" cy="777240"/>
           </a:xfrm>
           <a:prstGeom prst="rect">
@@ -20764,7 +20764,7 @@
         </p:nvSpPr>
         <p:spPr>
           <a:xfrm>
-            <a:off x="594360" y="1307592"/>
+            <a:off x="594360" y="1986270"/>
             <a:ext cx="7955279" cy="164592"/>
           </a:xfrm>
           <a:prstGeom prst="rect">
@@ -21046,7 +21046,7 @@
         </p:nvSpPr>
         <p:spPr>
           <a:xfrm>
-            <a:off x="548640" y="1508760"/>
+            <a:off x="548640" y="2155580"/>
             <a:ext cx="8046720" cy="825500"/>
           </a:xfrm>
           <a:prstGeom prst="rect">
@@ -21149,7 +21149,7 @@
         </p:nvSpPr>
         <p:spPr>
           <a:xfrm>
-            <a:off x="594360" y="2535428"/>
+            <a:off x="594360" y="3182248"/>
             <a:ext cx="7955279" cy="777240"/>
           </a:xfrm>
           <a:prstGeom prst="rect">
@@ -21294,7 +21294,7 @@
         </p:nvSpPr>
         <p:spPr>
           <a:xfrm>
-            <a:off x="594360" y="1307592"/>
+            <a:off x="594360" y="1954412"/>
             <a:ext cx="7955279" cy="164592"/>
           </a:xfrm>
           <a:prstGeom prst="rect">
@@ -21462,7 +21462,7 @@
         </p:nvSpPr>
         <p:spPr>
           <a:xfrm>
-            <a:off x="548640" y="1508760"/>
+            <a:off x="548640" y="1917442"/>
             <a:ext cx="8046720" cy="1301750"/>
           </a:xfrm>
           <a:prstGeom prst="rect">
@@ -21627,7 +21627,7 @@
         </p:nvSpPr>
         <p:spPr>
           <a:xfrm>
-            <a:off x="594360" y="3011678"/>
+            <a:off x="594360" y="3420360"/>
             <a:ext cx="7955279" cy="777240"/>
           </a:xfrm>
           <a:prstGeom prst="rect">
@@ -21772,7 +21772,7 @@
         </p:nvSpPr>
         <p:spPr>
           <a:xfrm>
-            <a:off x="594360" y="1307592"/>
+            <a:off x="594360" y="1716274"/>
             <a:ext cx="7955279" cy="164592"/>
           </a:xfrm>
           <a:prstGeom prst="rect">
@@ -21940,7 +21940,7 @@
         </p:nvSpPr>
         <p:spPr>
           <a:xfrm>
-            <a:off x="548640" y="1508760"/>
+            <a:off x="548640" y="2172020"/>
             <a:ext cx="8046720" cy="793750"/>
           </a:xfrm>
           <a:prstGeom prst="rect">
@@ -22043,7 +22043,7 @@
         </p:nvSpPr>
         <p:spPr>
           <a:xfrm>
-            <a:off x="594360" y="2503678"/>
+            <a:off x="594360" y="3166938"/>
             <a:ext cx="7955279" cy="777240"/>
           </a:xfrm>
           <a:prstGeom prst="rect">
@@ -22188,7 +22188,7 @@
         </p:nvSpPr>
         <p:spPr>
           <a:xfrm>
-            <a:off x="594360" y="1307592"/>
+            <a:off x="594360" y="1970852"/>
             <a:ext cx="7955279" cy="164592"/>
           </a:xfrm>
           <a:prstGeom prst="rect">
@@ -22356,7 +22356,7 @@
         </p:nvSpPr>
         <p:spPr>
           <a:xfrm>
-            <a:off x="548640" y="1508760"/>
+            <a:off x="548640" y="2326217"/>
             <a:ext cx="8046720" cy="484187"/>
           </a:xfrm>
           <a:prstGeom prst="rect">
@@ -22428,7 +22428,7 @@
         </p:nvSpPr>
         <p:spPr>
           <a:xfrm>
-            <a:off x="594360" y="2194115"/>
+            <a:off x="594360" y="3011572"/>
             <a:ext cx="7955279" cy="777240"/>
           </a:xfrm>
           <a:prstGeom prst="rect">
@@ -22573,7 +22573,7 @@
         </p:nvSpPr>
         <p:spPr>
           <a:xfrm>
-            <a:off x="594360" y="1307592"/>
+            <a:off x="594360" y="2125049"/>
             <a:ext cx="7955279" cy="164592"/>
           </a:xfrm>
           <a:prstGeom prst="rect">
@@ -22741,7 +22741,7 @@
         </p:nvSpPr>
         <p:spPr>
           <a:xfrm>
-            <a:off x="548640" y="1508760"/>
+            <a:off x="548640" y="2155580"/>
             <a:ext cx="8046720" cy="825500"/>
           </a:xfrm>
           <a:prstGeom prst="rect">
@@ -22844,7 +22844,7 @@
         </p:nvSpPr>
         <p:spPr>
           <a:xfrm>
-            <a:off x="594360" y="2535428"/>
+            <a:off x="594360" y="3182248"/>
             <a:ext cx="7955279" cy="777240"/>
           </a:xfrm>
           <a:prstGeom prst="rect">
@@ -22989,7 +22989,7 @@
         </p:nvSpPr>
         <p:spPr>
           <a:xfrm>
-            <a:off x="594360" y="1307592"/>
+            <a:off x="594360" y="1954412"/>
             <a:ext cx="7955279" cy="164592"/>
           </a:xfrm>
           <a:prstGeom prst="rect">
@@ -23157,7 +23157,7 @@
         </p:nvSpPr>
         <p:spPr>
           <a:xfrm>
-            <a:off x="548640" y="1508760"/>
+            <a:off x="548640" y="2227646"/>
             <a:ext cx="8046720" cy="682625"/>
           </a:xfrm>
           <a:prstGeom prst="rect">
@@ -23260,7 +23260,7 @@
         </p:nvSpPr>
         <p:spPr>
           <a:xfrm>
-            <a:off x="594360" y="2392553"/>
+            <a:off x="594360" y="3111439"/>
             <a:ext cx="7955279" cy="777240"/>
           </a:xfrm>
           <a:prstGeom prst="rect">
@@ -23405,7 +23405,7 @@
         </p:nvSpPr>
         <p:spPr>
           <a:xfrm>
-            <a:off x="594360" y="1307592"/>
+            <a:off x="594360" y="2026478"/>
             <a:ext cx="7955279" cy="164592"/>
           </a:xfrm>
           <a:prstGeom prst="rect">
@@ -23573,7 +23573,7 @@
         </p:nvSpPr>
         <p:spPr>
           <a:xfrm>
-            <a:off x="548640" y="1508760"/>
+            <a:off x="548640" y="2155580"/>
             <a:ext cx="8046720" cy="825500"/>
           </a:xfrm>
           <a:prstGeom prst="rect">
@@ -23676,7 +23676,7 @@
         </p:nvSpPr>
         <p:spPr>
           <a:xfrm>
-            <a:off x="594360" y="2535428"/>
+            <a:off x="594360" y="3182248"/>
             <a:ext cx="7955279" cy="777240"/>
           </a:xfrm>
           <a:prstGeom prst="rect">
@@ -23821,7 +23821,7 @@
         </p:nvSpPr>
         <p:spPr>
           <a:xfrm>
-            <a:off x="594360" y="1307592"/>
+            <a:off x="594360" y="1954412"/>
             <a:ext cx="7955279" cy="164592"/>
           </a:xfrm>
           <a:prstGeom prst="rect">
@@ -23989,7 +23989,7 @@
         </p:nvSpPr>
         <p:spPr>
           <a:xfrm>
-            <a:off x="548640" y="1508760"/>
+            <a:off x="548640" y="2172020"/>
             <a:ext cx="8046720" cy="793750"/>
           </a:xfrm>
           <a:prstGeom prst="rect">
@@ -24092,7 +24092,7 @@
         </p:nvSpPr>
         <p:spPr>
           <a:xfrm>
-            <a:off x="594360" y="2503678"/>
+            <a:off x="594360" y="3166938"/>
             <a:ext cx="7955279" cy="777240"/>
           </a:xfrm>
           <a:prstGeom prst="rect">
@@ -24237,7 +24237,7 @@
         </p:nvSpPr>
         <p:spPr>
           <a:xfrm>
-            <a:off x="594360" y="1307592"/>
+            <a:off x="594360" y="1970852"/>
             <a:ext cx="7955279" cy="164592"/>
           </a:xfrm>
           <a:prstGeom prst="rect">
@@ -35288,7 +35288,7 @@
         </p:nvSpPr>
         <p:spPr>
           <a:xfrm>
-            <a:off x="548640" y="1508760"/>
+            <a:off x="548640" y="2171417"/>
             <a:ext cx="8046720" cy="793750"/>
           </a:xfrm>
           <a:prstGeom prst="rect">
@@ -35391,7 +35391,7 @@
         </p:nvSpPr>
         <p:spPr>
           <a:xfrm>
-            <a:off x="594360" y="2503678"/>
+            <a:off x="594360" y="3166335"/>
             <a:ext cx="7955279" cy="777240"/>
           </a:xfrm>
           <a:prstGeom prst="rect">
@@ -35536,7 +35536,7 @@
         </p:nvSpPr>
         <p:spPr>
           <a:xfrm>
-            <a:off x="594360" y="1307592"/>
+            <a:off x="594360" y="1970249"/>
             <a:ext cx="7955279" cy="164592"/>
           </a:xfrm>
           <a:prstGeom prst="rect">

</xml_diff>

<commit_message>
Proofread swe-bench-verified slides page by page with Gemini
</commit_message>
<xml_diff>
--- a/slides/datasets-in-10-minutes-swe-bench-verified.pptx
+++ b/slides/datasets-in-10-minutes-swe-bench-verified.pptx
@@ -7447,8 +7447,8 @@
                 <a:ea typeface="Noto Sans CJK JP"/>
                 <a:cs typeface="Noto Sans"/>
               </a:rPr>
-              <a:t>GitHubの不具合報告を読み、コードを修正する
-人が検証した500課題で評価するデータセット</a:t>
+              <a:t>GitHubの不具合報告を読み、コードを修正する能力を
+人間が検証した500課題で評価するデータセット</a:t>
             </a:r>
           </a:p>
         </p:txBody>
@@ -11503,23 +11503,23 @@
                 <a:spcPct val="110000"/>
               </a:lnSpc>
               <a:buNone/>
-              <a:defRPr sz="2800" b="0">
-                <a:solidFill>
-                  <a:srgbClr val="303437"/>
-                </a:solidFill>
-                <a:latin typeface="Noto Sans"/>
-              </a:defRPr>
-            </a:pPr>
-            <a:r>
-              <a:rPr sz="2800" b="1" lang="ja-JP" altLang="en-US">
-                <a:solidFill>
-                  <a:srgbClr val="303437"/>
-                </a:solidFill>
-                <a:latin typeface="Noto Sans"/>
-                <a:ea typeface="Noto Sans CJK JP"/>
-                <a:cs typeface="Noto Sans"/>
-              </a:rPr>
-              <a:t>解決率は、解決した課題数を全課題数で割る</a:t>
+              <a:defRPr sz="2500" b="0">
+                <a:solidFill>
+                  <a:srgbClr val="303437"/>
+                </a:solidFill>
+                <a:latin typeface="Noto Sans"/>
+              </a:defRPr>
+            </a:pPr>
+            <a:r>
+              <a:rPr sz="2500" b="1" lang="ja-JP" altLang="en-US">
+                <a:solidFill>
+                  <a:srgbClr val="303437"/>
+                </a:solidFill>
+                <a:latin typeface="Noto Sans"/>
+                <a:ea typeface="Noto Sans CJK JP"/>
+                <a:cs typeface="Noto Sans"/>
+              </a:rPr>
+              <a:t>解決率は、解決した課題数を全課題数で割って算出する</a:t>
             </a:r>
           </a:p>
         </p:txBody>
@@ -13315,7 +13315,7 @@
                 <a:ea typeface="Noto Sans CJK JP"/>
                 <a:cs typeface="Noto Sans"/>
               </a:rPr>
-              <a:t>マージ済みで、Issueを解決し、テストファイルも変更したPull Requestを候補にする。</a:t>
+              <a:t>マージ済みで、Issueを解決し、テストファイルも変更したPull Requestを候補とした。</a:t>
             </a:r>
           </a:p>
           <a:p>
@@ -15773,7 +15773,7 @@
                 <a:ea typeface="Noto Sans CJK JP"/>
                 <a:cs typeface="Noto Sans"/>
               </a:rPr>
-              <a:t>参照修正は1ファイルが429課題</a:t>
+              <a:t>参照パッチが1ファイルの課題は429件</a:t>
             </a:r>
           </a:p>
         </p:txBody>
@@ -18280,7 +18280,7 @@
                 <a:ea typeface="Noto Sans CJK JP"/>
                 <a:cs typeface="Noto Sans"/>
               </a:rPr>
-              <a:t>SWE-Bench Proは別の、長い作業を含む評価</a:t>
+              <a:t>SWE-Bench Proは長時間の作業を扱う別の評価</a:t>
             </a:r>
           </a:p>
         </p:txBody>
@@ -18894,23 +18894,23 @@
                 <a:spcPct val="110000"/>
               </a:lnSpc>
               <a:buNone/>
-              <a:defRPr sz="2800" b="0">
-                <a:solidFill>
-                  <a:srgbClr val="303437"/>
-                </a:solidFill>
-                <a:latin typeface="Noto Sans"/>
-              </a:defRPr>
-            </a:pPr>
-            <a:r>
-              <a:rPr sz="2800" b="1" lang="ja-JP" altLang="en-US">
-                <a:solidFill>
-                  <a:srgbClr val="303437"/>
-                </a:solidFill>
-                <a:latin typeface="Noto Sans"/>
-                <a:ea typeface="Noto Sans CJK JP"/>
-                <a:cs typeface="Noto Sans"/>
-              </a:rPr>
-              <a:t>候補パッチを渡し、テスト実行とレポートを得る</a:t>
+              <a:defRPr sz="2500" b="0">
+                <a:solidFill>
+                  <a:srgbClr val="303437"/>
+                </a:solidFill>
+                <a:latin typeface="Noto Sans"/>
+              </a:defRPr>
+            </a:pPr>
+            <a:r>
+              <a:rPr sz="2500" b="1" lang="ja-JP" altLang="en-US">
+                <a:solidFill>
+                  <a:srgbClr val="303437"/>
+                </a:solidFill>
+                <a:latin typeface="Noto Sans"/>
+                <a:ea typeface="Noto Sans CJK JP"/>
+                <a:cs typeface="Noto Sans"/>
+              </a:rPr>
+              <a:t>候補パッチを渡し、テストを実行してレポートを得る</a:t>
             </a:r>
           </a:p>
         </p:txBody>
@@ -19383,7 +19383,7 @@
                 <a:ea typeface="Noto Sans CJK JP"/>
                 <a:cs typeface="Noto Sans"/>
               </a:rPr>
-              <a:t>モデルはIssueとリポジトリからパッチを作り、不具合を直すテストと既存動作の維持を確認する。</a:t>
+              <a:t>モデルはIssueとリポジトリからパッチを作り、不具合の修正と既存動作の維持をテストで確認する。</a:t>
             </a:r>
           </a:p>
           <a:p>
@@ -22084,7 +22084,7 @@
                 <a:ea typeface="Noto Sans CJK JP"/>
                 <a:cs typeface="Noto Sans"/>
               </a:rPr>
-              <a:t>Seaborn：大きな数の凡例で倍率が表示されず、値が誤って読める。参照修正は、凡例でオフセットと科学表記を使わない設定にする。</a:t>
+              <a:t>Seaborn：大きな数の凡例で倍率が表示されず、値が誤って読み取られる。参照修正は、凡例でオフセットと科学表記を使わない設定にする。</a:t>
             </a:r>
           </a:p>
         </p:txBody>
@@ -28949,7 +28949,7 @@
                 <a:ea typeface="Noto Sans CJK JP"/>
                 <a:cs typeface="Noto Sans"/>
               </a:rPr>
-              <a:t>500件のproblem_statement.mdで前後の空白を除き、</a:t>
+              <a:t>500件のproblem_statement.mdから前後の空白を除き、</a:t>
             </a:r>
           </a:p>
           <a:p>
@@ -32214,7 +32214,7 @@
                 <a:ea typeface="Noto Sans CJK JP"/>
                 <a:cs typeface="Noto Sans"/>
               </a:rPr>
-              <a:t>実Issueの修正を評価にした研究者たち</a:t>
+              <a:t>実Issueの修正を評価対象にした研究者たち</a:t>
             </a:r>
           </a:p>
         </p:txBody>
@@ -32687,7 +32687,7 @@
                           <a:ea typeface="Noto Sans CJK JP"/>
                           <a:cs typeface="Noto Sans"/>
                         </a:rPr>
-                        <a:t>課題に含まれるもの</a:t>
+                        <a:t>内容</a:t>
                       </a:r>
                     </a:p>
                   </a:txBody>

</xml_diff>